<commit_message>
modificato un ultima volta il pdf tecnologie
</commit_message>
<xml_diff>
--- a/RTB/TECNOLOGIE/Tecnologie.pptx
+++ b/RTB/TECNOLOGIE/Tecnologie.pptx
@@ -3472,65 +3472,6 @@
         </a:p>
       </dgm:t>
     </dgm:pt>
-    <dgm:pt modelId="{3850311C-A53C-4052-BDD5-F5866951D844}">
-      <dgm:prSet custT="1"/>
-      <dgm:spPr>
-        <a:solidFill>
-          <a:srgbClr val="FFFAEF">
-            <a:alpha val="90000"/>
-          </a:srgbClr>
-        </a:solidFill>
-      </dgm:spPr>
-      <dgm:t>
-        <a:bodyPr/>
-        <a:lstStyle/>
-        <a:p>
-          <a:pPr>
-            <a:buFont typeface="Arial" panose="020B0604020202020204" pitchFamily="34" charset="0"/>
-            <a:buChar char="•"/>
-          </a:pPr>
-          <a:r>
-            <a:rPr lang="it-IT" sz="2200" b="1" dirty="0" err="1"/>
-            <a:t>Angular</a:t>
-          </a:r>
-          <a:r>
-            <a:rPr lang="it-IT" sz="2200" b="1" dirty="0"/>
-            <a:t> (v21) in </a:t>
-          </a:r>
-          <a:r>
-            <a:rPr lang="it-IT" sz="2200" b="1" dirty="0" err="1"/>
-            <a:t>TypeScript</a:t>
-          </a:r>
-          <a:r>
-            <a:rPr lang="it-IT" sz="2200" b="1" dirty="0"/>
-            <a:t> su ambiente Node.js v24</a:t>
-          </a:r>
-          <a:endParaRPr lang="en-US" sz="2200" dirty="0"/>
-        </a:p>
-      </dgm:t>
-    </dgm:pt>
-    <dgm:pt modelId="{1093B51F-1E48-46C6-B64A-7D72D2D61ACC}" type="parTrans" cxnId="{27F0BE87-1F53-4513-854E-A9EF65EBF7FE}">
-      <dgm:prSet/>
-      <dgm:spPr/>
-      <dgm:t>
-        <a:bodyPr/>
-        <a:lstStyle/>
-        <a:p>
-          <a:endParaRPr lang="it-IT"/>
-        </a:p>
-      </dgm:t>
-    </dgm:pt>
-    <dgm:pt modelId="{B85F275C-6B08-4B47-A49E-6839949226DE}" type="sibTrans" cxnId="{27F0BE87-1F53-4513-854E-A9EF65EBF7FE}">
-      <dgm:prSet/>
-      <dgm:spPr/>
-      <dgm:t>
-        <a:bodyPr/>
-        <a:lstStyle/>
-        <a:p>
-          <a:endParaRPr lang="it-IT"/>
-        </a:p>
-      </dgm:t>
-    </dgm:pt>
     <dgm:pt modelId="{81C5FAF5-7969-428F-9168-FEA62E83FEE0}">
       <dgm:prSet custT="1"/>
       <dgm:spPr>
@@ -3753,6 +3694,208 @@
         </a:p>
       </dgm:t>
     </dgm:pt>
+    <dgm:pt modelId="{EE76E364-6A46-492A-9FD7-63C775ADA808}">
+      <dgm:prSet custT="1"/>
+      <dgm:spPr/>
+      <dgm:t>
+        <a:bodyPr/>
+        <a:lstStyle/>
+        <a:p>
+          <a:r>
+            <a:rPr lang="it-IT" sz="2200" b="1" dirty="0" err="1"/>
+            <a:t>Frontend</a:t>
+          </a:r>
+          <a:r>
+            <a:rPr lang="it-IT" sz="2200" b="1" dirty="0"/>
+            <a:t> - </a:t>
+          </a:r>
+          <a:r>
+            <a:rPr lang="it-IT" sz="2200" b="1" dirty="0" err="1"/>
+            <a:t>Angular</a:t>
+          </a:r>
+          <a:endParaRPr lang="en-US" sz="2200" dirty="0"/>
+        </a:p>
+      </dgm:t>
+    </dgm:pt>
+    <dgm:pt modelId="{119AEC78-9891-4081-85AD-AAE5114E48ED}" type="sibTrans" cxnId="{8ADAB9E6-BB3B-4581-9B45-07948A4AEA67}">
+      <dgm:prSet/>
+      <dgm:spPr/>
+      <dgm:t>
+        <a:bodyPr/>
+        <a:lstStyle/>
+        <a:p>
+          <a:endParaRPr lang="en-US"/>
+        </a:p>
+      </dgm:t>
+    </dgm:pt>
+    <dgm:pt modelId="{522B9AE2-1358-4DCB-B21B-51AD7A4CC3B6}" type="parTrans" cxnId="{8ADAB9E6-BB3B-4581-9B45-07948A4AEA67}">
+      <dgm:prSet/>
+      <dgm:spPr/>
+      <dgm:t>
+        <a:bodyPr/>
+        <a:lstStyle/>
+        <a:p>
+          <a:endParaRPr lang="en-US"/>
+        </a:p>
+      </dgm:t>
+    </dgm:pt>
+    <dgm:pt modelId="{E81EBE7F-1B29-4F3B-9D90-F27A5F52A4F7}">
+      <dgm:prSet custT="1"/>
+      <dgm:spPr>
+        <a:solidFill>
+          <a:srgbClr val="FFFAEF">
+            <a:alpha val="90000"/>
+          </a:srgbClr>
+        </a:solidFill>
+      </dgm:spPr>
+      <dgm:t>
+        <a:bodyPr/>
+        <a:lstStyle/>
+        <a:p>
+          <a:pPr>
+            <a:buFont typeface="Arial" panose="020B0604020202020204" pitchFamily="34" charset="0"/>
+            <a:buNone/>
+          </a:pPr>
+          <a:r>
+            <a:rPr lang="it-IT" sz="2200" b="1" dirty="0" err="1"/>
+            <a:t>Angular</a:t>
+          </a:r>
+          <a:r>
+            <a:rPr lang="it-IT" sz="2200" b="1" dirty="0"/>
+            <a:t> (v21) su ambiente Node.js v24</a:t>
+          </a:r>
+          <a:endParaRPr lang="en-US" sz="2200" dirty="0"/>
+        </a:p>
+      </dgm:t>
+    </dgm:pt>
+    <dgm:pt modelId="{901F6192-51CD-49F4-8A54-859AB828A347}" type="parTrans" cxnId="{8C265198-3772-4E2A-AD6C-ABEF95119153}">
+      <dgm:prSet/>
+      <dgm:spPr/>
+      <dgm:t>
+        <a:bodyPr/>
+        <a:lstStyle/>
+        <a:p>
+          <a:endParaRPr lang="it-IT"/>
+        </a:p>
+      </dgm:t>
+    </dgm:pt>
+    <dgm:pt modelId="{3D557813-893F-4AAA-9A58-5F46E98736F6}" type="sibTrans" cxnId="{8C265198-3772-4E2A-AD6C-ABEF95119153}">
+      <dgm:prSet/>
+      <dgm:spPr/>
+      <dgm:t>
+        <a:bodyPr/>
+        <a:lstStyle/>
+        <a:p>
+          <a:endParaRPr lang="it-IT"/>
+        </a:p>
+      </dgm:t>
+    </dgm:pt>
+    <dgm:pt modelId="{47035833-554B-4E51-989B-BBBA7CB2F1B2}">
+      <dgm:prSet custT="1"/>
+      <dgm:spPr>
+        <a:solidFill>
+          <a:srgbClr val="FFFAEF">
+            <a:alpha val="90000"/>
+          </a:srgbClr>
+        </a:solidFill>
+      </dgm:spPr>
+      <dgm:t>
+        <a:bodyPr/>
+        <a:lstStyle/>
+        <a:p>
+          <a:pPr>
+            <a:buFont typeface="Arial" panose="020B0604020202020204" pitchFamily="34" charset="0"/>
+            <a:buNone/>
+          </a:pPr>
+          <a:r>
+            <a:rPr lang="en-US" sz="2200" b="0" dirty="0" err="1"/>
+            <a:t>Scelta</a:t>
+          </a:r>
+          <a:r>
+            <a:rPr lang="en-US" sz="2200" b="0" dirty="0"/>
+            <a:t> di </a:t>
+          </a:r>
+          <a:r>
+            <a:rPr lang="en-US" sz="2200" b="1" dirty="0"/>
+            <a:t>Angular Vs React:</a:t>
+          </a:r>
+          <a:endParaRPr lang="en-US" sz="2200" dirty="0"/>
+        </a:p>
+      </dgm:t>
+    </dgm:pt>
+    <dgm:pt modelId="{90EBB25F-9B48-4B19-B9EE-674C6F7D6E33}" type="parTrans" cxnId="{C4653128-9530-4777-A348-542D422C2F4C}">
+      <dgm:prSet/>
+      <dgm:spPr/>
+      <dgm:t>
+        <a:bodyPr/>
+        <a:lstStyle/>
+        <a:p>
+          <a:endParaRPr lang="it-IT"/>
+        </a:p>
+      </dgm:t>
+    </dgm:pt>
+    <dgm:pt modelId="{D685D6C1-2BC9-402B-BD46-4FA2EE1F5CC1}" type="sibTrans" cxnId="{C4653128-9530-4777-A348-542D422C2F4C}">
+      <dgm:prSet/>
+      <dgm:spPr/>
+      <dgm:t>
+        <a:bodyPr/>
+        <a:lstStyle/>
+        <a:p>
+          <a:endParaRPr lang="it-IT"/>
+        </a:p>
+      </dgm:t>
+    </dgm:pt>
+    <dgm:pt modelId="{9D2878A0-3308-49D9-9E8B-BB7B16C5666C}">
+      <dgm:prSet custT="1"/>
+      <dgm:spPr>
+        <a:solidFill>
+          <a:srgbClr val="FFFAEF">
+            <a:alpha val="90000"/>
+          </a:srgbClr>
+        </a:solidFill>
+      </dgm:spPr>
+      <dgm:t>
+        <a:bodyPr/>
+        <a:lstStyle/>
+        <a:p>
+          <a:pPr>
+            <a:buFont typeface="Arial" panose="020B0604020202020204" pitchFamily="34" charset="0"/>
+            <a:buChar char="•"/>
+          </a:pPr>
+          <a:r>
+            <a:rPr lang="en-US" sz="2200" dirty="0"/>
+            <a:t>Framework vs </a:t>
+          </a:r>
+          <a:r>
+            <a:rPr lang="en-US" sz="2200" dirty="0" err="1"/>
+            <a:t>libreria</a:t>
+          </a:r>
+          <a:endParaRPr lang="en-US" sz="2200" dirty="0"/>
+        </a:p>
+      </dgm:t>
+    </dgm:pt>
+    <dgm:pt modelId="{2C603990-4AF4-4301-850D-F66262D359B2}" type="parTrans" cxnId="{AEF394F9-D7FB-464B-AFA5-C5B843046B96}">
+      <dgm:prSet/>
+      <dgm:spPr/>
+      <dgm:t>
+        <a:bodyPr/>
+        <a:lstStyle/>
+        <a:p>
+          <a:endParaRPr lang="it-IT"/>
+        </a:p>
+      </dgm:t>
+    </dgm:pt>
+    <dgm:pt modelId="{BDB38DF0-81C7-4A1C-BFE2-56278E86F3DB}" type="sibTrans" cxnId="{AEF394F9-D7FB-464B-AFA5-C5B843046B96}">
+      <dgm:prSet/>
+      <dgm:spPr/>
+      <dgm:t>
+        <a:bodyPr/>
+        <a:lstStyle/>
+        <a:p>
+          <a:endParaRPr lang="it-IT"/>
+        </a:p>
+      </dgm:t>
+    </dgm:pt>
     <dgm:pt modelId="{3ACFCC25-7784-4356-B8DF-A35CF2CC5237}">
       <dgm:prSet custT="1"/>
       <dgm:spPr>
@@ -3798,7 +3941,7 @@
         </a:p>
       </dgm:t>
     </dgm:pt>
-    <dgm:pt modelId="{1FFA7EC9-892D-4681-A9B1-5FE3969C5613}" type="parTrans" cxnId="{C62AC98E-E928-42FA-A277-7F38775C0B7E}">
+    <dgm:pt modelId="{1FFA7EC9-892D-4681-A9B1-5FE3969C5613}" type="parTrans" cxnId="{157AD865-39E9-4394-AD26-FA162D902D24}">
       <dgm:prSet/>
       <dgm:spPr/>
       <dgm:t>
@@ -3809,7 +3952,7 @@
         </a:p>
       </dgm:t>
     </dgm:pt>
-    <dgm:pt modelId="{423D80BF-E726-4A72-8017-67F8D9F24CD1}" type="sibTrans" cxnId="{C62AC98E-E928-42FA-A277-7F38775C0B7E}">
+    <dgm:pt modelId="{423D80BF-E726-4A72-8017-67F8D9F24CD1}" type="sibTrans" cxnId="{157AD865-39E9-4394-AD26-FA162D902D24}">
       <dgm:prSet/>
       <dgm:spPr/>
       <dgm:t>
@@ -3820,48 +3963,151 @@
         </a:p>
       </dgm:t>
     </dgm:pt>
-    <dgm:pt modelId="{EE76E364-6A46-492A-9FD7-63C775ADA808}">
+    <dgm:pt modelId="{3083C0AC-5FAE-4A98-AD65-B00E46317EAA}">
       <dgm:prSet custT="1"/>
-      <dgm:spPr/>
+      <dgm:spPr>
+        <a:solidFill>
+          <a:srgbClr val="FFFAEF">
+            <a:alpha val="90000"/>
+          </a:srgbClr>
+        </a:solidFill>
+      </dgm:spPr>
       <dgm:t>
         <a:bodyPr/>
         <a:lstStyle/>
         <a:p>
-          <a:r>
-            <a:rPr lang="it-IT" sz="2200" b="1" dirty="0" err="1"/>
-            <a:t>Frontend</a:t>
-          </a:r>
-          <a:r>
-            <a:rPr lang="it-IT" sz="2200" b="1" dirty="0"/>
-            <a:t> - </a:t>
-          </a:r>
-          <a:r>
-            <a:rPr lang="it-IT" sz="2200" b="1" dirty="0" err="1"/>
-            <a:t>Angular</a:t>
-          </a:r>
-          <a:endParaRPr lang="en-US" sz="2200" dirty="0"/>
+          <a:pPr>
+            <a:buFont typeface="Arial" panose="020B0604020202020204" pitchFamily="34" charset="0"/>
+            <a:buNone/>
+          </a:pPr>
+          <a:r>
+            <a:rPr lang="en-US" sz="2200" b="1" dirty="0"/>
+            <a:t>Angular </a:t>
+          </a:r>
+          <a:r>
+            <a:rPr lang="en-US" sz="2200" b="1" dirty="0" err="1"/>
+            <a:t>nel</a:t>
+          </a:r>
+          <a:r>
+            <a:rPr lang="en-US" sz="2200" b="1" dirty="0"/>
+            <a:t> nostro POC:</a:t>
+          </a:r>
         </a:p>
       </dgm:t>
     </dgm:pt>
-    <dgm:pt modelId="{119AEC78-9891-4081-85AD-AAE5114E48ED}" type="sibTrans" cxnId="{8ADAB9E6-BB3B-4581-9B45-07948A4AEA67}">
+    <dgm:pt modelId="{6D46ADC7-98F1-4B44-8ABD-9CF9E2656DEB}" type="parTrans" cxnId="{F7EA5785-3780-49CB-8439-3772D648A86E}">
       <dgm:prSet/>
       <dgm:spPr/>
       <dgm:t>
         <a:bodyPr/>
         <a:lstStyle/>
         <a:p>
-          <a:endParaRPr lang="en-US"/>
+          <a:endParaRPr lang="it-IT"/>
         </a:p>
       </dgm:t>
     </dgm:pt>
-    <dgm:pt modelId="{522B9AE2-1358-4DCB-B21B-51AD7A4CC3B6}" type="parTrans" cxnId="{8ADAB9E6-BB3B-4581-9B45-07948A4AEA67}">
+    <dgm:pt modelId="{24B2D5EA-2F1B-49BD-ACC9-DCDED6EDC43F}" type="sibTrans" cxnId="{F7EA5785-3780-49CB-8439-3772D648A86E}">
       <dgm:prSet/>
       <dgm:spPr/>
       <dgm:t>
         <a:bodyPr/>
         <a:lstStyle/>
         <a:p>
-          <a:endParaRPr lang="en-US"/>
+          <a:endParaRPr lang="it-IT"/>
+        </a:p>
+      </dgm:t>
+    </dgm:pt>
+    <dgm:pt modelId="{1E54DBF2-0B1C-465C-A75E-DD6A16A0630B}">
+      <dgm:prSet custT="1"/>
+      <dgm:spPr>
+        <a:solidFill>
+          <a:srgbClr val="FFFAEF">
+            <a:alpha val="90000"/>
+          </a:srgbClr>
+        </a:solidFill>
+      </dgm:spPr>
+      <dgm:t>
+        <a:bodyPr/>
+        <a:lstStyle/>
+        <a:p>
+          <a:pPr>
+            <a:buFont typeface="Arial" panose="020B0604020202020204" pitchFamily="34" charset="0"/>
+            <a:buChar char="•"/>
+          </a:pPr>
+          <a:r>
+            <a:rPr lang="en-US" sz="2200" dirty="0"/>
+            <a:t>OOP vs </a:t>
+          </a:r>
+          <a:r>
+            <a:rPr lang="en-US" sz="2200" dirty="0" err="1"/>
+            <a:t>funzionale</a:t>
+          </a:r>
+          <a:endParaRPr lang="en-US" sz="2200" dirty="0"/>
+        </a:p>
+      </dgm:t>
+    </dgm:pt>
+    <dgm:pt modelId="{E34D0822-23EB-47BC-B7A4-28DE0FA75F12}" type="parTrans" cxnId="{1746BAF4-7F83-4E61-BBA9-235227B536CB}">
+      <dgm:prSet/>
+      <dgm:spPr/>
+      <dgm:t>
+        <a:bodyPr/>
+        <a:lstStyle/>
+        <a:p>
+          <a:endParaRPr lang="it-IT"/>
+        </a:p>
+      </dgm:t>
+    </dgm:pt>
+    <dgm:pt modelId="{65F8CC45-709D-41D6-88A2-C7DB84C09C2B}" type="sibTrans" cxnId="{1746BAF4-7F83-4E61-BBA9-235227B536CB}">
+      <dgm:prSet/>
+      <dgm:spPr/>
+      <dgm:t>
+        <a:bodyPr/>
+        <a:lstStyle/>
+        <a:p>
+          <a:endParaRPr lang="it-IT"/>
+        </a:p>
+      </dgm:t>
+    </dgm:pt>
+    <dgm:pt modelId="{C07C55AE-257E-4178-8EDE-747334E3BDE5}">
+      <dgm:prSet custT="1"/>
+      <dgm:spPr>
+        <a:solidFill>
+          <a:srgbClr val="FFFAEF">
+            <a:alpha val="90000"/>
+          </a:srgbClr>
+        </a:solidFill>
+      </dgm:spPr>
+      <dgm:t>
+        <a:bodyPr/>
+        <a:lstStyle/>
+        <a:p>
+          <a:pPr>
+            <a:buFont typeface="Arial" panose="020B0604020202020204" pitchFamily="34" charset="0"/>
+            <a:buNone/>
+          </a:pPr>
+          <a:endParaRPr lang="en-US" sz="2200" dirty="0"/>
+        </a:p>
+      </dgm:t>
+    </dgm:pt>
+    <dgm:pt modelId="{57396DED-E5BD-47EF-A274-349AC9A0A616}" type="parTrans" cxnId="{AE67C9F9-2F25-47CF-A235-1DBDA1B04B18}">
+      <dgm:prSet/>
+      <dgm:spPr/>
+      <dgm:t>
+        <a:bodyPr/>
+        <a:lstStyle/>
+        <a:p>
+          <a:endParaRPr lang="it-IT"/>
+        </a:p>
+      </dgm:t>
+    </dgm:pt>
+    <dgm:pt modelId="{F966E27C-520B-4A2A-9EB2-BFF87F80813F}" type="sibTrans" cxnId="{AE67C9F9-2F25-47CF-A235-1DBDA1B04B18}">
+      <dgm:prSet/>
+      <dgm:spPr/>
+      <dgm:t>
+        <a:bodyPr/>
+        <a:lstStyle/>
+        <a:p>
+          <a:endParaRPr lang="it-IT"/>
         </a:p>
       </dgm:t>
     </dgm:pt>
@@ -3897,7 +4143,7 @@
       <dgm:spPr/>
     </dgm:pt>
     <dgm:pt modelId="{8A748C3E-CE62-4E92-A0FE-1F5548AC9D02}" type="pres">
-      <dgm:prSet presAssocID="{EE76E364-6A46-492A-9FD7-63C775ADA808}" presName="childText" presStyleLbl="conFgAcc1" presStyleIdx="0" presStyleCnt="1" custScaleY="105478" custLinFactNeighborX="3710" custLinFactNeighborY="-27338">
+      <dgm:prSet presAssocID="{EE76E364-6A46-492A-9FD7-63C775ADA808}" presName="childText" presStyleLbl="conFgAcc1" presStyleIdx="0" presStyleCnt="1" custScaleY="94239" custLinFactNeighborX="-3786" custLinFactNeighborY="-40692">
         <dgm:presLayoutVars>
           <dgm:bulletEnabled val="1"/>
         </dgm:presLayoutVars>
@@ -3906,33 +4152,43 @@
     </dgm:pt>
   </dgm:ptLst>
   <dgm:cxnLst>
-    <dgm:cxn modelId="{D95E0A08-3823-456F-B045-8B2D181525F8}" type="presOf" srcId="{BCA671DB-9D16-4302-B7A8-56BF6E3543A9}" destId="{8A748C3E-CE62-4E92-A0FE-1F5548AC9D02}" srcOrd="0" destOrd="2" presId="urn:microsoft.com/office/officeart/2005/8/layout/list1"/>
-    <dgm:cxn modelId="{E9092709-6E91-45E0-A7A5-3A0CB221696B}" type="presOf" srcId="{EE76E364-6A46-492A-9FD7-63C775ADA808}" destId="{0E75AC4A-956D-493C-A82B-572CF3B1603B}" srcOrd="0" destOrd="0" presId="urn:microsoft.com/office/officeart/2005/8/layout/list1"/>
-    <dgm:cxn modelId="{0A628414-F6B5-42E1-A8F3-0CB3833C4BF6}" type="presOf" srcId="{81C5FAF5-7969-428F-9168-FEA62E83FEE0}" destId="{8A748C3E-CE62-4E92-A0FE-1F5548AC9D02}" srcOrd="0" destOrd="4" presId="urn:microsoft.com/office/officeart/2005/8/layout/list1"/>
-    <dgm:cxn modelId="{248A3716-A158-479A-925B-4FBEDA81A7A4}" srcId="{EE76E364-6A46-492A-9FD7-63C775ADA808}" destId="{81C5FAF5-7969-428F-9168-FEA62E83FEE0}" srcOrd="4" destOrd="0" parTransId="{F85420F4-2BF4-48A2-BC52-21EE60C7088A}" sibTransId="{76ECC8FB-B797-4F4E-8993-577D9FE42A74}"/>
-    <dgm:cxn modelId="{13F49D19-F08F-4F3F-8DFA-171716C82016}" type="presOf" srcId="{F5F55255-3B4A-4616-B6F8-0A66537C5D82}" destId="{8A748C3E-CE62-4E92-A0FE-1F5548AC9D02}" srcOrd="0" destOrd="6" presId="urn:microsoft.com/office/officeart/2005/8/layout/list1"/>
-    <dgm:cxn modelId="{DA525E1A-7FFF-4B9B-979A-37830A1A6822}" type="presOf" srcId="{24C10798-75D1-47C0-A4DB-CA289CC5805B}" destId="{8A748C3E-CE62-4E92-A0FE-1F5548AC9D02}" srcOrd="0" destOrd="7" presId="urn:microsoft.com/office/officeart/2005/8/layout/list1"/>
-    <dgm:cxn modelId="{9C280A1C-C029-4E7F-999E-A84766E633AD}" type="presOf" srcId="{3ACFCC25-7784-4356-B8DF-A35CF2CC5237}" destId="{8A748C3E-CE62-4E92-A0FE-1F5548AC9D02}" srcOrd="0" destOrd="3" presId="urn:microsoft.com/office/officeart/2005/8/layout/list1"/>
-    <dgm:cxn modelId="{89A26634-7323-49E3-997A-5445C4214B35}" srcId="{EE76E364-6A46-492A-9FD7-63C775ADA808}" destId="{EA4C9FAE-8632-437A-94BC-F7324DD67615}" srcOrd="5" destOrd="0" parTransId="{933F93DC-F2BC-4901-9B93-BEDA7E1295ED}" sibTransId="{18CF30EE-9734-4EDB-80FF-201F7A903B36}"/>
+    <dgm:cxn modelId="{D9D7BA05-199F-4FE9-9878-0E591DD851B2}" type="presOf" srcId="{147F1B68-2F1B-4E54-A64E-FDF57E94FBAE}" destId="{8A748C3E-CE62-4E92-A0FE-1F5548AC9D02}" srcOrd="0" destOrd="13" presId="urn:microsoft.com/office/officeart/2005/8/layout/list1"/>
+    <dgm:cxn modelId="{14B98007-77D4-4912-903C-B59BB2A0071F}" type="presOf" srcId="{9D2878A0-3308-49D9-9E8B-BB7B16C5666C}" destId="{8A748C3E-CE62-4E92-A0FE-1F5548AC9D02}" srcOrd="0" destOrd="4" presId="urn:microsoft.com/office/officeart/2005/8/layout/list1"/>
+    <dgm:cxn modelId="{248A3716-A158-479A-925B-4FBEDA81A7A4}" srcId="{EE76E364-6A46-492A-9FD7-63C775ADA808}" destId="{81C5FAF5-7969-428F-9168-FEA62E83FEE0}" srcOrd="9" destOrd="0" parTransId="{F85420F4-2BF4-48A2-BC52-21EE60C7088A}" sibTransId="{76ECC8FB-B797-4F4E-8993-577D9FE42A74}"/>
+    <dgm:cxn modelId="{3D640618-1354-4F40-9A9D-E62C774DB987}" type="presOf" srcId="{F5F55255-3B4A-4616-B6F8-0A66537C5D82}" destId="{8A748C3E-CE62-4E92-A0FE-1F5548AC9D02}" srcOrd="0" destOrd="11" presId="urn:microsoft.com/office/officeart/2005/8/layout/list1"/>
+    <dgm:cxn modelId="{840D5C1D-67E8-40B6-B6FE-29E3426538FE}" type="presOf" srcId="{81C5FAF5-7969-428F-9168-FEA62E83FEE0}" destId="{8A748C3E-CE62-4E92-A0FE-1F5548AC9D02}" srcOrd="0" destOrd="9" presId="urn:microsoft.com/office/officeart/2005/8/layout/list1"/>
+    <dgm:cxn modelId="{C4653128-9530-4777-A348-542D422C2F4C}" srcId="{EE76E364-6A46-492A-9FD7-63C775ADA808}" destId="{47035833-554B-4E51-989B-BBBA7CB2F1B2}" srcOrd="3" destOrd="0" parTransId="{90EBB25F-9B48-4B19-B9EE-674C6F7D6E33}" sibTransId="{D685D6C1-2BC9-402B-BD46-4FA2EE1F5CC1}"/>
+    <dgm:cxn modelId="{89A26634-7323-49E3-997A-5445C4214B35}" srcId="{EE76E364-6A46-492A-9FD7-63C775ADA808}" destId="{EA4C9FAE-8632-437A-94BC-F7324DD67615}" srcOrd="10" destOrd="0" parTransId="{933F93DC-F2BC-4901-9B93-BEDA7E1295ED}" sibTransId="{18CF30EE-9734-4EDB-80FF-201F7A903B36}"/>
     <dgm:cxn modelId="{0C848A3D-3553-4924-8D80-54F69669587F}" type="presOf" srcId="{228ADC0D-83DA-40CE-9EF2-B2A23B2BA12F}" destId="{529C8736-509C-426A-B1AF-D9FE39FB5B28}" srcOrd="0" destOrd="0" presId="urn:microsoft.com/office/officeart/2005/8/layout/list1"/>
-    <dgm:cxn modelId="{628B0D5B-E06C-4FD6-A68C-4484D8743AE9}" type="presOf" srcId="{147F1B68-2F1B-4E54-A64E-FDF57E94FBAE}" destId="{8A748C3E-CE62-4E92-A0FE-1F5548AC9D02}" srcOrd="0" destOrd="8" presId="urn:microsoft.com/office/officeart/2005/8/layout/list1"/>
-    <dgm:cxn modelId="{AF834E48-FD81-433D-B1B2-2CCD7D74765A}" srcId="{EE76E364-6A46-492A-9FD7-63C775ADA808}" destId="{BCA671DB-9D16-4302-B7A8-56BF6E3543A9}" srcOrd="2" destOrd="0" parTransId="{E2DB0A18-721A-4D89-AC8F-ECFB539A4977}" sibTransId="{EC660C46-8325-4A10-8E43-5BBCD693556D}"/>
+    <dgm:cxn modelId="{C2BA9945-9B20-45E7-AF9B-689821493901}" type="presOf" srcId="{FB7856FD-14F6-497F-A96F-439DE861ECA4}" destId="{8A748C3E-CE62-4E92-A0FE-1F5548AC9D02}" srcOrd="0" destOrd="0" presId="urn:microsoft.com/office/officeart/2005/8/layout/list1"/>
+    <dgm:cxn modelId="{157AD865-39E9-4394-AD26-FA162D902D24}" srcId="{EE76E364-6A46-492A-9FD7-63C775ADA808}" destId="{3ACFCC25-7784-4356-B8DF-A35CF2CC5237}" srcOrd="8" destOrd="0" parTransId="{1FFA7EC9-892D-4681-A9B1-5FE3969C5613}" sibTransId="{423D80BF-E726-4A72-8017-67F8D9F24CD1}"/>
+    <dgm:cxn modelId="{AF834E48-FD81-433D-B1B2-2CCD7D74765A}" srcId="{EE76E364-6A46-492A-9FD7-63C775ADA808}" destId="{BCA671DB-9D16-4302-B7A8-56BF6E3543A9}" srcOrd="7" destOrd="0" parTransId="{E2DB0A18-721A-4D89-AC8F-ECFB539A4977}" sibTransId="{EC660C46-8325-4A10-8E43-5BBCD693556D}"/>
     <dgm:cxn modelId="{F609747B-AE71-4ACA-93A0-5C6C9FA2C6E1}" srcId="{EE76E364-6A46-492A-9FD7-63C775ADA808}" destId="{FB7856FD-14F6-497F-A96F-439DE861ECA4}" srcOrd="0" destOrd="0" parTransId="{B2A71A46-24A2-44C1-B6DD-257439AFBC0A}" sibTransId="{AED585D0-E158-48D1-8037-5DB08D2C892B}"/>
+    <dgm:cxn modelId="{B3BC947E-A5B7-4BD5-83C5-0F0990E73AA5}" type="presOf" srcId="{EE76E364-6A46-492A-9FD7-63C775ADA808}" destId="{0E75AC4A-956D-493C-A82B-572CF3B1603B}" srcOrd="0" destOrd="0" presId="urn:microsoft.com/office/officeart/2005/8/layout/list1"/>
     <dgm:cxn modelId="{32E73583-EC60-44EC-A1BF-54C8775B331D}" srcId="{EA4C9FAE-8632-437A-94BC-F7324DD67615}" destId="{24C10798-75D1-47C0-A4DB-CA289CC5805B}" srcOrd="1" destOrd="0" parTransId="{CCB71030-2EA5-4506-92EC-221C09CE28D3}" sibTransId="{ACEF8760-0D4C-4F48-B99C-551EED1CF848}"/>
-    <dgm:cxn modelId="{27F0BE87-1F53-4513-854E-A9EF65EBF7FE}" srcId="{EE76E364-6A46-492A-9FD7-63C775ADA808}" destId="{3850311C-A53C-4052-BDD5-F5866951D844}" srcOrd="1" destOrd="0" parTransId="{1093B51F-1E48-46C6-B64A-7D72D2D61ACC}" sibTransId="{B85F275C-6B08-4B47-A49E-6839949226DE}"/>
-    <dgm:cxn modelId="{D3DDFC8D-E675-4B05-8D8F-1BB4A9CE7573}" type="presOf" srcId="{3850311C-A53C-4052-BDD5-F5866951D844}" destId="{8A748C3E-CE62-4E92-A0FE-1F5548AC9D02}" srcOrd="0" destOrd="1" presId="urn:microsoft.com/office/officeart/2005/8/layout/list1"/>
-    <dgm:cxn modelId="{C62AC98E-E928-42FA-A277-7F38775C0B7E}" srcId="{EE76E364-6A46-492A-9FD7-63C775ADA808}" destId="{3ACFCC25-7784-4356-B8DF-A35CF2CC5237}" srcOrd="3" destOrd="0" parTransId="{1FFA7EC9-892D-4681-A9B1-5FE3969C5613}" sibTransId="{423D80BF-E726-4A72-8017-67F8D9F24CD1}"/>
-    <dgm:cxn modelId="{EDA2B0A6-6285-42C8-ACD6-A0ED11956F63}" srcId="{EE76E364-6A46-492A-9FD7-63C775ADA808}" destId="{147F1B68-2F1B-4E54-A64E-FDF57E94FBAE}" srcOrd="6" destOrd="0" parTransId="{BB5E3B85-D782-4999-882E-B3E92E827653}" sibTransId="{7A783848-5787-4168-A501-C8A8796F4A23}"/>
+    <dgm:cxn modelId="{F7EA5785-3780-49CB-8439-3772D648A86E}" srcId="{EE76E364-6A46-492A-9FD7-63C775ADA808}" destId="{3083C0AC-5FAE-4A98-AD65-B00E46317EAA}" srcOrd="6" destOrd="0" parTransId="{6D46ADC7-98F1-4B44-8ABD-9CF9E2656DEB}" sibTransId="{24B2D5EA-2F1B-49BD-ACC9-DCDED6EDC43F}"/>
+    <dgm:cxn modelId="{8C265198-3772-4E2A-AD6C-ABEF95119153}" srcId="{EE76E364-6A46-492A-9FD7-63C775ADA808}" destId="{E81EBE7F-1B29-4F3B-9D90-F27A5F52A4F7}" srcOrd="1" destOrd="0" parTransId="{901F6192-51CD-49F4-8A54-859AB828A347}" sibTransId="{3D557813-893F-4AAA-9A58-5F46E98736F6}"/>
+    <dgm:cxn modelId="{84876A9C-E00F-443E-A7E6-6DD38906E2FB}" type="presOf" srcId="{E81EBE7F-1B29-4F3B-9D90-F27A5F52A4F7}" destId="{8A748C3E-CE62-4E92-A0FE-1F5548AC9D02}" srcOrd="0" destOrd="1" presId="urn:microsoft.com/office/officeart/2005/8/layout/list1"/>
+    <dgm:cxn modelId="{EDA2B0A6-6285-42C8-ACD6-A0ED11956F63}" srcId="{EE76E364-6A46-492A-9FD7-63C775ADA808}" destId="{147F1B68-2F1B-4E54-A64E-FDF57E94FBAE}" srcOrd="11" destOrd="0" parTransId="{BB5E3B85-D782-4999-882E-B3E92E827653}" sibTransId="{7A783848-5787-4168-A501-C8A8796F4A23}"/>
+    <dgm:cxn modelId="{B76A21A7-70BB-44B5-B32D-C58036ECCDA6}" type="presOf" srcId="{BCA671DB-9D16-4302-B7A8-56BF6E3543A9}" destId="{8A748C3E-CE62-4E92-A0FE-1F5548AC9D02}" srcOrd="0" destOrd="7" presId="urn:microsoft.com/office/officeart/2005/8/layout/list1"/>
     <dgm:cxn modelId="{D3CD3EAD-7193-4575-98B5-F9317CE4FB43}" srcId="{EA4C9FAE-8632-437A-94BC-F7324DD67615}" destId="{F5F55255-3B4A-4616-B6F8-0A66537C5D82}" srcOrd="0" destOrd="0" parTransId="{AF394C79-B2A6-4DCB-885D-CE8D2685EC33}" sibTransId="{E6592C2A-BD5F-424A-817B-CCDA29892586}"/>
-    <dgm:cxn modelId="{A22FD4B2-7A35-4E88-9759-5C8856D49BA3}" type="presOf" srcId="{EA4C9FAE-8632-437A-94BC-F7324DD67615}" destId="{8A748C3E-CE62-4E92-A0FE-1F5548AC9D02}" srcOrd="0" destOrd="5" presId="urn:microsoft.com/office/officeart/2005/8/layout/list1"/>
-    <dgm:cxn modelId="{A1F187D5-2309-485A-9E59-78CEC5B4B9EB}" type="presOf" srcId="{EE76E364-6A46-492A-9FD7-63C775ADA808}" destId="{EF67F11A-FCD0-4E59-A23F-17BCC3FB1182}" srcOrd="1" destOrd="0" presId="urn:microsoft.com/office/officeart/2005/8/layout/list1"/>
+    <dgm:cxn modelId="{F84649BA-7494-44A8-B0DE-BA2DCD49178C}" type="presOf" srcId="{EA4C9FAE-8632-437A-94BC-F7324DD67615}" destId="{8A748C3E-CE62-4E92-A0FE-1F5548AC9D02}" srcOrd="0" destOrd="10" presId="urn:microsoft.com/office/officeart/2005/8/layout/list1"/>
+    <dgm:cxn modelId="{BFE189BB-5BD9-4F0A-BD9B-543D5DD3CE84}" type="presOf" srcId="{C07C55AE-257E-4178-8EDE-747334E3BDE5}" destId="{8A748C3E-CE62-4E92-A0FE-1F5548AC9D02}" srcOrd="0" destOrd="2" presId="urn:microsoft.com/office/officeart/2005/8/layout/list1"/>
+    <dgm:cxn modelId="{AE4F18C4-3F5E-4FD9-A2F6-D226C34980FB}" type="presOf" srcId="{3ACFCC25-7784-4356-B8DF-A35CF2CC5237}" destId="{8A748C3E-CE62-4E92-A0FE-1F5548AC9D02}" srcOrd="0" destOrd="8" presId="urn:microsoft.com/office/officeart/2005/8/layout/list1"/>
+    <dgm:cxn modelId="{A3B613D5-E298-425B-9F5F-232D5869B052}" type="presOf" srcId="{47035833-554B-4E51-989B-BBBA7CB2F1B2}" destId="{8A748C3E-CE62-4E92-A0FE-1F5548AC9D02}" srcOrd="0" destOrd="3" presId="urn:microsoft.com/office/officeart/2005/8/layout/list1"/>
+    <dgm:cxn modelId="{09F294D5-E7D0-4977-AFCF-473D4E4CF3FD}" type="presOf" srcId="{3083C0AC-5FAE-4A98-AD65-B00E46317EAA}" destId="{8A748C3E-CE62-4E92-A0FE-1F5548AC9D02}" srcOrd="0" destOrd="6" presId="urn:microsoft.com/office/officeart/2005/8/layout/list1"/>
     <dgm:cxn modelId="{8ADAB9E6-BB3B-4581-9B45-07948A4AEA67}" srcId="{228ADC0D-83DA-40CE-9EF2-B2A23B2BA12F}" destId="{EE76E364-6A46-492A-9FD7-63C775ADA808}" srcOrd="0" destOrd="0" parTransId="{522B9AE2-1358-4DCB-B21B-51AD7A4CC3B6}" sibTransId="{119AEC78-9891-4081-85AD-AAE5114E48ED}"/>
-    <dgm:cxn modelId="{4F9365FF-2D6F-4D0D-9E60-1782CBB99FAC}" type="presOf" srcId="{FB7856FD-14F6-497F-A96F-439DE861ECA4}" destId="{8A748C3E-CE62-4E92-A0FE-1F5548AC9D02}" srcOrd="0" destOrd="0" presId="urn:microsoft.com/office/officeart/2005/8/layout/list1"/>
-    <dgm:cxn modelId="{5070C104-B1E1-40F1-A0DE-97F4F4CD7310}" type="presParOf" srcId="{529C8736-509C-426A-B1AF-D9FE39FB5B28}" destId="{8BC7EA25-256B-410A-8E19-CC15A19D412A}" srcOrd="0" destOrd="0" presId="urn:microsoft.com/office/officeart/2005/8/layout/list1"/>
-    <dgm:cxn modelId="{204DA009-B3F1-4225-839C-DF0A8826F00A}" type="presParOf" srcId="{8BC7EA25-256B-410A-8E19-CC15A19D412A}" destId="{0E75AC4A-956D-493C-A82B-572CF3B1603B}" srcOrd="0" destOrd="0" presId="urn:microsoft.com/office/officeart/2005/8/layout/list1"/>
-    <dgm:cxn modelId="{D8782D56-DDA4-486D-8333-D9521FAE6776}" type="presParOf" srcId="{8BC7EA25-256B-410A-8E19-CC15A19D412A}" destId="{EF67F11A-FCD0-4E59-A23F-17BCC3FB1182}" srcOrd="1" destOrd="0" presId="urn:microsoft.com/office/officeart/2005/8/layout/list1"/>
-    <dgm:cxn modelId="{836B591A-C28B-4C37-AF15-8B5DBC70DA21}" type="presParOf" srcId="{529C8736-509C-426A-B1AF-D9FE39FB5B28}" destId="{E84E3A97-5D14-4C15-B06F-E00215B154CE}" srcOrd="1" destOrd="0" presId="urn:microsoft.com/office/officeart/2005/8/layout/list1"/>
-    <dgm:cxn modelId="{8BA68BD2-7FDC-4C1D-AF1A-DD92BF1A2A14}" type="presParOf" srcId="{529C8736-509C-426A-B1AF-D9FE39FB5B28}" destId="{8A748C3E-CE62-4E92-A0FE-1F5548AC9D02}" srcOrd="2" destOrd="0" presId="urn:microsoft.com/office/officeart/2005/8/layout/list1"/>
+    <dgm:cxn modelId="{3BB3C8E8-AC4E-47D2-9540-45FFF6AC9690}" type="presOf" srcId="{EE76E364-6A46-492A-9FD7-63C775ADA808}" destId="{EF67F11A-FCD0-4E59-A23F-17BCC3FB1182}" srcOrd="1" destOrd="0" presId="urn:microsoft.com/office/officeart/2005/8/layout/list1"/>
+    <dgm:cxn modelId="{BC9D0CF3-EF2F-4E70-8F4F-A14AED17E420}" type="presOf" srcId="{1E54DBF2-0B1C-465C-A75E-DD6A16A0630B}" destId="{8A748C3E-CE62-4E92-A0FE-1F5548AC9D02}" srcOrd="0" destOrd="5" presId="urn:microsoft.com/office/officeart/2005/8/layout/list1"/>
+    <dgm:cxn modelId="{1746BAF4-7F83-4E61-BBA9-235227B536CB}" srcId="{EE76E364-6A46-492A-9FD7-63C775ADA808}" destId="{1E54DBF2-0B1C-465C-A75E-DD6A16A0630B}" srcOrd="5" destOrd="0" parTransId="{E34D0822-23EB-47BC-B7A4-28DE0FA75F12}" sibTransId="{65F8CC45-709D-41D6-88A2-C7DB84C09C2B}"/>
+    <dgm:cxn modelId="{A8A3D9F5-A188-48D3-9244-3B98C42FF9F0}" type="presOf" srcId="{24C10798-75D1-47C0-A4DB-CA289CC5805B}" destId="{8A748C3E-CE62-4E92-A0FE-1F5548AC9D02}" srcOrd="0" destOrd="12" presId="urn:microsoft.com/office/officeart/2005/8/layout/list1"/>
+    <dgm:cxn modelId="{AEF394F9-D7FB-464B-AFA5-C5B843046B96}" srcId="{EE76E364-6A46-492A-9FD7-63C775ADA808}" destId="{9D2878A0-3308-49D9-9E8B-BB7B16C5666C}" srcOrd="4" destOrd="0" parTransId="{2C603990-4AF4-4301-850D-F66262D359B2}" sibTransId="{BDB38DF0-81C7-4A1C-BFE2-56278E86F3DB}"/>
+    <dgm:cxn modelId="{AE67C9F9-2F25-47CF-A235-1DBDA1B04B18}" srcId="{EE76E364-6A46-492A-9FD7-63C775ADA808}" destId="{C07C55AE-257E-4178-8EDE-747334E3BDE5}" srcOrd="2" destOrd="0" parTransId="{57396DED-E5BD-47EF-A274-349AC9A0A616}" sibTransId="{F966E27C-520B-4A2A-9EB2-BFF87F80813F}"/>
+    <dgm:cxn modelId="{46739878-F7F4-4DB2-B6EC-852151A5BAB4}" type="presParOf" srcId="{529C8736-509C-426A-B1AF-D9FE39FB5B28}" destId="{8BC7EA25-256B-410A-8E19-CC15A19D412A}" srcOrd="0" destOrd="0" presId="urn:microsoft.com/office/officeart/2005/8/layout/list1"/>
+    <dgm:cxn modelId="{AAA9F26B-8633-42E9-8A07-EB7505929DFA}" type="presParOf" srcId="{8BC7EA25-256B-410A-8E19-CC15A19D412A}" destId="{0E75AC4A-956D-493C-A82B-572CF3B1603B}" srcOrd="0" destOrd="0" presId="urn:microsoft.com/office/officeart/2005/8/layout/list1"/>
+    <dgm:cxn modelId="{375EA17A-C483-494B-86F4-F3D979469F7B}" type="presParOf" srcId="{8BC7EA25-256B-410A-8E19-CC15A19D412A}" destId="{EF67F11A-FCD0-4E59-A23F-17BCC3FB1182}" srcOrd="1" destOrd="0" presId="urn:microsoft.com/office/officeart/2005/8/layout/list1"/>
+    <dgm:cxn modelId="{288997A1-1D30-41D7-8465-C8BDAEED12F1}" type="presParOf" srcId="{529C8736-509C-426A-B1AF-D9FE39FB5B28}" destId="{E84E3A97-5D14-4C15-B06F-E00215B154CE}" srcOrd="1" destOrd="0" presId="urn:microsoft.com/office/officeart/2005/8/layout/list1"/>
+    <dgm:cxn modelId="{0D8241A1-F9B5-4371-8D1A-64873B9BF75A}" type="presParOf" srcId="{529C8736-509C-426A-B1AF-D9FE39FB5B28}" destId="{8A748C3E-CE62-4E92-A0FE-1F5548AC9D02}" srcOrd="2" destOrd="0" presId="urn:microsoft.com/office/officeart/2005/8/layout/list1"/>
   </dgm:cxnLst>
   <dgm:bg/>
   <dgm:whole/>
@@ -5592,8 +5848,8 @@
       </dsp:nvSpPr>
       <dsp:spPr>
         <a:xfrm>
-          <a:off x="0" y="52113"/>
-          <a:ext cx="7086599" cy="5980602"/>
+          <a:off x="0" y="0"/>
+          <a:ext cx="8382000" cy="6483266"/>
         </a:xfrm>
         <a:prstGeom prst="rect">
           <a:avLst/>
@@ -5629,7 +5885,7 @@
         <a:fontRef idx="minor"/>
       </dsp:style>
       <dsp:txBody>
-        <a:bodyPr spcFirstLastPara="0" vert="horz" wrap="square" lIns="549999" tIns="1041400" rIns="549999" bIns="156464" numCol="1" spcCol="1270" anchor="t" anchorCtr="0">
+        <a:bodyPr spcFirstLastPara="0" vert="horz" wrap="square" lIns="650536" tIns="728980" rIns="650536" bIns="156464" numCol="1" spcCol="1270" anchor="t" anchorCtr="0">
           <a:noAutofit/>
         </a:bodyPr>
         <a:lstStyle/>
@@ -5660,7 +5916,7 @@
               <a:spcPct val="15000"/>
             </a:spcAft>
             <a:buFont typeface="Arial" panose="020B0604020202020204" pitchFamily="34" charset="0"/>
-            <a:buChar char="•"/>
+            <a:buNone/>
           </a:pPr>
           <a:r>
             <a:rPr lang="it-IT" sz="2200" b="1" kern="1200" dirty="0" err="1"/>
@@ -5668,15 +5924,51 @@
           </a:r>
           <a:r>
             <a:rPr lang="it-IT" sz="2200" b="1" kern="1200" dirty="0"/>
-            <a:t> (v21) in </a:t>
-          </a:r>
-          <a:r>
-            <a:rPr lang="it-IT" sz="2200" b="1" kern="1200" dirty="0" err="1"/>
-            <a:t>TypeScript</a:t>
-          </a:r>
-          <a:r>
-            <a:rPr lang="it-IT" sz="2200" b="1" kern="1200" dirty="0"/>
-            <a:t> su ambiente Node.js v24</a:t>
+            <a:t> (v21) su ambiente Node.js v24</a:t>
+          </a:r>
+          <a:endParaRPr lang="en-US" sz="2200" kern="1200" dirty="0"/>
+        </a:p>
+        <a:p>
+          <a:pPr marL="228600" lvl="1" indent="-228600" algn="l" defTabSz="977900">
+            <a:lnSpc>
+              <a:spcPct val="90000"/>
+            </a:lnSpc>
+            <a:spcBef>
+              <a:spcPct val="0"/>
+            </a:spcBef>
+            <a:spcAft>
+              <a:spcPct val="15000"/>
+            </a:spcAft>
+            <a:buFont typeface="Arial" panose="020B0604020202020204" pitchFamily="34" charset="0"/>
+            <a:buNone/>
+          </a:pPr>
+          <a:endParaRPr lang="en-US" sz="2200" kern="1200" dirty="0"/>
+        </a:p>
+        <a:p>
+          <a:pPr marL="228600" lvl="1" indent="-228600" algn="l" defTabSz="977900">
+            <a:lnSpc>
+              <a:spcPct val="90000"/>
+            </a:lnSpc>
+            <a:spcBef>
+              <a:spcPct val="0"/>
+            </a:spcBef>
+            <a:spcAft>
+              <a:spcPct val="15000"/>
+            </a:spcAft>
+            <a:buFont typeface="Arial" panose="020B0604020202020204" pitchFamily="34" charset="0"/>
+            <a:buNone/>
+          </a:pPr>
+          <a:r>
+            <a:rPr lang="en-US" sz="2200" b="0" kern="1200" dirty="0" err="1"/>
+            <a:t>Scelta</a:t>
+          </a:r>
+          <a:r>
+            <a:rPr lang="en-US" sz="2200" b="0" kern="1200" dirty="0"/>
+            <a:t> di </a:t>
+          </a:r>
+          <a:r>
+            <a:rPr lang="en-US" sz="2200" b="1" kern="1200" dirty="0"/>
+            <a:t>Angular Vs React:</a:t>
           </a:r>
           <a:endParaRPr lang="en-US" sz="2200" kern="1200" dirty="0"/>
         </a:p>
@@ -5696,63 +5988,11 @@
           </a:pPr>
           <a:r>
             <a:rPr lang="en-US" sz="2200" kern="1200" dirty="0"/>
-            <a:t>Progettazione in </a:t>
-          </a:r>
-          <a:r>
-            <a:rPr lang="en-US" sz="2200" b="1" kern="1200" dirty="0"/>
-            <a:t>Components, </a:t>
-          </a:r>
-          <a:r>
-            <a:rPr lang="en-US" sz="2200" b="0" kern="1200" dirty="0" err="1"/>
-            <a:t>ognuno</a:t>
-          </a:r>
-          <a:r>
-            <a:rPr lang="en-US" sz="2200" b="0" kern="1200" dirty="0"/>
-            <a:t> </a:t>
-          </a:r>
-          <a:r>
-            <a:rPr lang="en-US" sz="2200" b="0" kern="1200" dirty="0" err="1"/>
-            <a:t>definisce</a:t>
-          </a:r>
-          <a:r>
-            <a:rPr lang="en-US" sz="2200" b="0" kern="1200" dirty="0"/>
-            <a:t> </a:t>
+            <a:t>Framework vs </a:t>
           </a:r>
           <a:r>
             <a:rPr lang="en-US" sz="2200" kern="1200" dirty="0" err="1"/>
-            <a:t>una</a:t>
-          </a:r>
-          <a:r>
-            <a:rPr lang="en-US" sz="2200" kern="1200" dirty="0"/>
-            <a:t> </a:t>
-          </a:r>
-          <a:r>
-            <a:rPr lang="en-US" sz="2200" kern="1200" dirty="0" err="1"/>
-            <a:t>singola</a:t>
-          </a:r>
-          <a:r>
-            <a:rPr lang="en-US" sz="2200" kern="1200" dirty="0"/>
-            <a:t> </a:t>
-          </a:r>
-          <a:r>
-            <a:rPr lang="en-US" sz="2200" kern="1200" dirty="0" err="1"/>
-            <a:t>pagina</a:t>
-          </a:r>
-          <a:r>
-            <a:rPr lang="en-US" sz="2200" kern="1200" dirty="0"/>
-            <a:t>: es. </a:t>
-          </a:r>
-          <a:r>
-            <a:rPr lang="it-IT" sz="2200" b="0" kern="1200" dirty="0" err="1"/>
-            <a:t>AiAssistant</a:t>
-          </a:r>
-          <a:r>
-            <a:rPr lang="en-US" sz="2200" kern="1200" dirty="0"/>
-            <a:t>, </a:t>
-          </a:r>
-          <a:r>
-            <a:rPr lang="it-IT" sz="2200" b="0" kern="1200" dirty="0" err="1"/>
-            <a:t>AiCopilot</a:t>
+            <a:t>libreria</a:t>
           </a:r>
           <a:endParaRPr lang="en-US" sz="2200" kern="1200" dirty="0"/>
         </a:p>
@@ -5772,29 +6012,40 @@
           </a:pPr>
           <a:r>
             <a:rPr lang="en-US" sz="2200" kern="1200" dirty="0"/>
-            <a:t>2 </a:t>
+            <a:t>OOP vs </a:t>
           </a:r>
           <a:r>
             <a:rPr lang="en-US" sz="2200" kern="1200" dirty="0" err="1"/>
-            <a:t>classi</a:t>
-          </a:r>
-          <a:r>
-            <a:rPr lang="en-US" sz="2200" kern="1200" dirty="0"/>
-            <a:t> di Servizi: </a:t>
-          </a:r>
-          <a:r>
-            <a:rPr lang="it-IT" sz="2200" b="0" kern="1200" dirty="0" err="1"/>
-            <a:t>ConversationsService</a:t>
-          </a:r>
-          <a:r>
-            <a:rPr lang="it-IT" sz="2200" b="0" kern="1200" dirty="0"/>
-            <a:t>, </a:t>
-          </a:r>
-          <a:r>
-            <a:rPr lang="it-IT" sz="2200" b="0" kern="1200" dirty="0" err="1"/>
-            <a:t>DocumentsService</a:t>
+            <a:t>funzionale</a:t>
           </a:r>
           <a:endParaRPr lang="en-US" sz="2200" kern="1200" dirty="0"/>
+        </a:p>
+        <a:p>
+          <a:pPr marL="228600" lvl="1" indent="-228600" algn="l" defTabSz="977900">
+            <a:lnSpc>
+              <a:spcPct val="90000"/>
+            </a:lnSpc>
+            <a:spcBef>
+              <a:spcPct val="0"/>
+            </a:spcBef>
+            <a:spcAft>
+              <a:spcPct val="15000"/>
+            </a:spcAft>
+            <a:buFont typeface="Arial" panose="020B0604020202020204" pitchFamily="34" charset="0"/>
+            <a:buNone/>
+          </a:pPr>
+          <a:r>
+            <a:rPr lang="en-US" sz="2200" b="1" kern="1200" dirty="0"/>
+            <a:t>Angular </a:t>
+          </a:r>
+          <a:r>
+            <a:rPr lang="en-US" sz="2200" b="1" kern="1200" dirty="0" err="1"/>
+            <a:t>nel</a:t>
+          </a:r>
+          <a:r>
+            <a:rPr lang="en-US" sz="2200" b="1" kern="1200" dirty="0"/>
+            <a:t> nostro POC:</a:t>
+          </a:r>
         </a:p>
         <a:p>
           <a:pPr marL="228600" lvl="1" indent="-228600" algn="l" defTabSz="977900">
@@ -5811,26 +6062,66 @@
             <a:buChar char="•"/>
           </a:pPr>
           <a:r>
-            <a:rPr lang="it-IT" sz="2200" kern="1200" dirty="0"/>
-            <a:t>architettura </a:t>
-          </a:r>
-          <a:r>
-            <a:rPr lang="it-IT" sz="2200" b="1" kern="1200" dirty="0"/>
-            <a:t>SPA</a:t>
-          </a:r>
-          <a:r>
-            <a:rPr lang="it-IT" sz="2200" kern="1200" dirty="0"/>
-            <a:t> basata su </a:t>
-          </a:r>
-          <a:r>
-            <a:rPr lang="it-IT" sz="2200" b="1" kern="1200" dirty="0" err="1"/>
-            <a:t>Angular</a:t>
-          </a:r>
-          <a:r>
-            <a:rPr lang="it-IT" sz="2200" b="1" kern="1200" dirty="0"/>
-            <a:t> Router</a:t>
-          </a:r>
-          <a:endParaRPr lang="en-US" sz="2200" b="1" kern="1200" dirty="0"/>
+            <a:rPr lang="en-US" sz="2200" kern="1200" dirty="0"/>
+            <a:t>Progettazione in </a:t>
+          </a:r>
+          <a:r>
+            <a:rPr lang="en-US" sz="2200" b="1" kern="1200" dirty="0"/>
+            <a:t>Components, </a:t>
+          </a:r>
+          <a:r>
+            <a:rPr lang="en-US" sz="2200" b="0" kern="1200" dirty="0" err="1"/>
+            <a:t>ognuno</a:t>
+          </a:r>
+          <a:r>
+            <a:rPr lang="en-US" sz="2200" b="0" kern="1200" dirty="0"/>
+            <a:t> </a:t>
+          </a:r>
+          <a:r>
+            <a:rPr lang="en-US" sz="2200" b="0" kern="1200" dirty="0" err="1"/>
+            <a:t>definisce</a:t>
+          </a:r>
+          <a:r>
+            <a:rPr lang="en-US" sz="2200" b="0" kern="1200" dirty="0"/>
+            <a:t> </a:t>
+          </a:r>
+          <a:r>
+            <a:rPr lang="en-US" sz="2200" kern="1200" dirty="0" err="1"/>
+            <a:t>una</a:t>
+          </a:r>
+          <a:r>
+            <a:rPr lang="en-US" sz="2200" kern="1200" dirty="0"/>
+            <a:t> </a:t>
+          </a:r>
+          <a:r>
+            <a:rPr lang="en-US" sz="2200" kern="1200" dirty="0" err="1"/>
+            <a:t>singola</a:t>
+          </a:r>
+          <a:r>
+            <a:rPr lang="en-US" sz="2200" kern="1200" dirty="0"/>
+            <a:t> </a:t>
+          </a:r>
+          <a:r>
+            <a:rPr lang="en-US" sz="2200" kern="1200" dirty="0" err="1"/>
+            <a:t>pagina</a:t>
+          </a:r>
+          <a:r>
+            <a:rPr lang="en-US" sz="2200" kern="1200" dirty="0"/>
+            <a:t>: es. </a:t>
+          </a:r>
+          <a:r>
+            <a:rPr lang="it-IT" sz="2200" b="0" kern="1200" dirty="0" err="1"/>
+            <a:t>AiAssistant</a:t>
+          </a:r>
+          <a:r>
+            <a:rPr lang="en-US" sz="2200" kern="1200" dirty="0"/>
+            <a:t>, </a:t>
+          </a:r>
+          <a:r>
+            <a:rPr lang="it-IT" sz="2200" b="0" kern="1200" dirty="0" err="1"/>
+            <a:t>AiCopilot</a:t>
+          </a:r>
+          <a:endParaRPr lang="en-US" sz="2200" kern="1200" dirty="0"/>
         </a:p>
         <a:p>
           <a:pPr marL="228600" lvl="1" indent="-228600" algn="l" defTabSz="977900">
@@ -5847,6 +6138,82 @@
             <a:buChar char="•"/>
           </a:pPr>
           <a:r>
+            <a:rPr lang="en-US" sz="2200" kern="1200" dirty="0"/>
+            <a:t>2 </a:t>
+          </a:r>
+          <a:r>
+            <a:rPr lang="en-US" sz="2200" kern="1200" dirty="0" err="1"/>
+            <a:t>classi</a:t>
+          </a:r>
+          <a:r>
+            <a:rPr lang="en-US" sz="2200" kern="1200" dirty="0"/>
+            <a:t> di Servizi: </a:t>
+          </a:r>
+          <a:r>
+            <a:rPr lang="it-IT" sz="2200" b="0" kern="1200" dirty="0" err="1"/>
+            <a:t>ConversationsService</a:t>
+          </a:r>
+          <a:r>
+            <a:rPr lang="it-IT" sz="2200" b="0" kern="1200" dirty="0"/>
+            <a:t>, </a:t>
+          </a:r>
+          <a:r>
+            <a:rPr lang="it-IT" sz="2200" b="0" kern="1200" dirty="0" err="1"/>
+            <a:t>DocumentsService</a:t>
+          </a:r>
+          <a:endParaRPr lang="en-US" sz="2200" kern="1200" dirty="0"/>
+        </a:p>
+        <a:p>
+          <a:pPr marL="228600" lvl="1" indent="-228600" algn="l" defTabSz="977900">
+            <a:lnSpc>
+              <a:spcPct val="90000"/>
+            </a:lnSpc>
+            <a:spcBef>
+              <a:spcPct val="0"/>
+            </a:spcBef>
+            <a:spcAft>
+              <a:spcPct val="15000"/>
+            </a:spcAft>
+            <a:buFont typeface="Arial" panose="020B0604020202020204" pitchFamily="34" charset="0"/>
+            <a:buChar char="•"/>
+          </a:pPr>
+          <a:r>
+            <a:rPr lang="it-IT" sz="2200" kern="1200" dirty="0"/>
+            <a:t>architettura </a:t>
+          </a:r>
+          <a:r>
+            <a:rPr lang="it-IT" sz="2200" b="1" kern="1200" dirty="0"/>
+            <a:t>SPA</a:t>
+          </a:r>
+          <a:r>
+            <a:rPr lang="it-IT" sz="2200" kern="1200" dirty="0"/>
+            <a:t> basata su </a:t>
+          </a:r>
+          <a:r>
+            <a:rPr lang="it-IT" sz="2200" b="1" kern="1200" dirty="0" err="1"/>
+            <a:t>Angular</a:t>
+          </a:r>
+          <a:r>
+            <a:rPr lang="it-IT" sz="2200" b="1" kern="1200" dirty="0"/>
+            <a:t> Router</a:t>
+          </a:r>
+          <a:endParaRPr lang="en-US" sz="2200" b="1" kern="1200" dirty="0"/>
+        </a:p>
+        <a:p>
+          <a:pPr marL="228600" lvl="1" indent="-228600" algn="l" defTabSz="977900">
+            <a:lnSpc>
+              <a:spcPct val="90000"/>
+            </a:lnSpc>
+            <a:spcBef>
+              <a:spcPct val="0"/>
+            </a:spcBef>
+            <a:spcAft>
+              <a:spcPct val="15000"/>
+            </a:spcAft>
+            <a:buFont typeface="Arial" panose="020B0604020202020204" pitchFamily="34" charset="0"/>
+            <a:buChar char="•"/>
+          </a:pPr>
+          <a:r>
             <a:rPr lang="it-IT" sz="2200" b="1" kern="1200" dirty="0" err="1"/>
             <a:t>RxJS</a:t>
           </a:r>
@@ -5943,8 +6310,8 @@
         </a:p>
       </dsp:txBody>
       <dsp:txXfrm>
-        <a:off x="0" y="52113"/>
-        <a:ext cx="7086599" cy="5980602"/>
+        <a:off x="0" y="0"/>
+        <a:ext cx="8382000" cy="6483266"/>
       </dsp:txXfrm>
     </dsp:sp>
     <dsp:sp modelId="{EF67F11A-FCD0-4E59-A23F-17BCC3FB1182}">
@@ -5954,8 +6321,8 @@
       </dsp:nvSpPr>
       <dsp:spPr>
         <a:xfrm>
-          <a:off x="532370" y="0"/>
-          <a:ext cx="4960619" cy="959503"/>
+          <a:off x="629685" y="0"/>
+          <a:ext cx="5867400" cy="997883"/>
         </a:xfrm>
         <a:prstGeom prst="roundRect">
           <a:avLst/>
@@ -6021,7 +6388,7 @@
         </a:fontRef>
       </dsp:style>
       <dsp:txBody>
-        <a:bodyPr spcFirstLastPara="0" vert="horz" wrap="square" lIns="187500" tIns="0" rIns="187500" bIns="0" numCol="1" spcCol="1270" anchor="ctr" anchorCtr="0">
+        <a:bodyPr spcFirstLastPara="0" vert="horz" wrap="square" lIns="221774" tIns="0" rIns="221774" bIns="0" numCol="1" spcCol="1270" anchor="ctr" anchorCtr="0">
           <a:noAutofit/>
         </a:bodyPr>
         <a:lstStyle/>
@@ -6054,8 +6421,8 @@
         </a:p>
       </dsp:txBody>
       <dsp:txXfrm>
-        <a:off x="579209" y="46839"/>
-        <a:ext cx="4866941" cy="865825"/>
+        <a:off x="678398" y="48713"/>
+        <a:ext cx="5769974" cy="900457"/>
       </dsp:txXfrm>
     </dsp:sp>
   </dsp:spTree>
@@ -12311,7 +12678,7 @@
           <a:p>
             <a:fld id="{7D0F7AA3-9057-4429-80B9-DC3D3FD0D30E}" type="datetimeFigureOut">
               <a:rPr lang="it-IT" smtClean="0"/>
-              <a:t>09/02/2026</a:t>
+              <a:t>12/02/2026</a:t>
             </a:fld>
             <a:endParaRPr lang="it-IT"/>
           </a:p>
@@ -12489,7 +12856,7 @@
           <a:p>
             <a:fld id="{DC233B30-4F8C-4A4C-AB5E-3B02323E36F5}" type="datetimeFigureOut">
               <a:rPr lang="it-IT" smtClean="0"/>
-              <a:t>09/02/2026</a:t>
+              <a:t>12/02/2026</a:t>
             </a:fld>
             <a:endParaRPr lang="it-IT"/>
           </a:p>
@@ -13027,7 +13394,7 @@
           <a:p>
             <a:fld id="{2AEBBCAD-870E-441A-8ABD-7498983D26CA}" type="datetime1">
               <a:rPr lang="en-US" smtClean="0"/>
-              <a:t>2/9/2026</a:t>
+              <a:t>2/12/2026</a:t>
             </a:fld>
             <a:endParaRPr lang="en-US"/>
           </a:p>
@@ -13191,7 +13558,7 @@
           <a:p>
             <a:fld id="{DBB619D4-11F3-4F3A-84A1-FD362988ED4B}" type="datetime1">
               <a:rPr lang="en-US" smtClean="0"/>
-              <a:t>2/9/2026</a:t>
+              <a:t>2/12/2026</a:t>
             </a:fld>
             <a:endParaRPr lang="en-US"/>
           </a:p>
@@ -13365,7 +13732,7 @@
           <a:p>
             <a:fld id="{9537A470-53D7-43F2-A38C-35EA5C3D9E3E}" type="datetime1">
               <a:rPr lang="en-US" smtClean="0"/>
-              <a:t>2/9/2026</a:t>
+              <a:t>2/12/2026</a:t>
             </a:fld>
             <a:endParaRPr lang="en-US"/>
           </a:p>
@@ -13529,7 +13896,7 @@
           <a:p>
             <a:fld id="{0CA91AF9-6521-45D8-81C8-C30E3165CD88}" type="datetime1">
               <a:rPr lang="en-US" smtClean="0"/>
-              <a:t>2/9/2026</a:t>
+              <a:t>2/12/2026</a:t>
             </a:fld>
             <a:endParaRPr lang="en-US"/>
           </a:p>
@@ -13770,7 +14137,7 @@
           <a:p>
             <a:fld id="{19ADD6C7-F40A-4EC5-A786-66FA25D032E8}" type="datetime1">
               <a:rPr lang="en-US" smtClean="0"/>
-              <a:t>2/9/2026</a:t>
+              <a:t>2/12/2026</a:t>
             </a:fld>
             <a:endParaRPr lang="en-US"/>
           </a:p>
@@ -14051,7 +14418,7 @@
           <a:p>
             <a:fld id="{73AF3211-BAC3-4D93-9598-8004ABF5F295}" type="datetime1">
               <a:rPr lang="en-US" smtClean="0"/>
-              <a:t>2/9/2026</a:t>
+              <a:t>2/12/2026</a:t>
             </a:fld>
             <a:endParaRPr lang="en-US"/>
           </a:p>
@@ -14466,7 +14833,7 @@
           <a:p>
             <a:fld id="{29EADF50-F9A2-4C97-A62A-50C60E010A22}" type="datetime1">
               <a:rPr lang="en-US" smtClean="0"/>
-              <a:t>2/9/2026</a:t>
+              <a:t>2/12/2026</a:t>
             </a:fld>
             <a:endParaRPr lang="en-US"/>
           </a:p>
@@ -14579,7 +14946,7 @@
           <a:p>
             <a:fld id="{DA927A00-663B-40A9-BEFA-F4F296EF78AF}" type="datetime1">
               <a:rPr lang="en-US" smtClean="0"/>
-              <a:t>2/9/2026</a:t>
+              <a:t>2/12/2026</a:t>
             </a:fld>
             <a:endParaRPr lang="en-US"/>
           </a:p>
@@ -14670,7 +15037,7 @@
           <a:p>
             <a:fld id="{130551C3-58EC-4AFE-B5E2-D1D9ADDB2862}" type="datetime1">
               <a:rPr lang="en-US" smtClean="0"/>
-              <a:t>2/9/2026</a:t>
+              <a:t>2/12/2026</a:t>
             </a:fld>
             <a:endParaRPr lang="en-US"/>
           </a:p>
@@ -14941,7 +15308,7 @@
           <a:p>
             <a:fld id="{C97796EB-1B2E-4E86-83B9-1E542E7481F4}" type="datetime1">
               <a:rPr lang="en-US" smtClean="0"/>
-              <a:t>2/9/2026</a:t>
+              <a:t>2/12/2026</a:t>
             </a:fld>
             <a:endParaRPr lang="en-US"/>
           </a:p>
@@ -15189,7 +15556,7 @@
           <a:p>
             <a:fld id="{F0DE7F15-0F43-40A0-8812-F3D41F61F70E}" type="datetime1">
               <a:rPr lang="en-US" smtClean="0"/>
-              <a:t>2/9/2026</a:t>
+              <a:t>2/12/2026</a:t>
             </a:fld>
             <a:endParaRPr lang="en-US"/>
           </a:p>
@@ -15396,7 +15763,7 @@
           <a:p>
             <a:fld id="{659F49B2-87B6-419A-8A54-1B4526018D64}" type="datetime1">
               <a:rPr lang="en-US" smtClean="0"/>
-              <a:t>2/9/2026</a:t>
+              <a:t>2/12/2026</a:t>
             </a:fld>
             <a:endParaRPr lang="en-US"/>
           </a:p>
@@ -16860,14 +17227,14 @@
           <p:nvPr>
             <p:extLst>
               <p:ext uri="{D42A27DB-BD31-4B8C-83A1-F6EECF244321}">
-                <p14:modId xmlns:p14="http://schemas.microsoft.com/office/powerpoint/2010/main" val="966120062"/>
+                <p14:modId xmlns:p14="http://schemas.microsoft.com/office/powerpoint/2010/main" val="3978282494"/>
               </p:ext>
             </p:extLst>
           </p:nvPr>
         </p:nvGraphicFramePr>
         <p:xfrm>
-          <a:off x="990600" y="3771900"/>
-          <a:ext cx="7086599" cy="6266835"/>
+          <a:off x="457200" y="3238500"/>
+          <a:ext cx="8382000" cy="6781800"/>
         </p:xfrm>
         <a:graphic>
           <a:graphicData uri="http://schemas.openxmlformats.org/drawingml/2006/diagram">
@@ -16902,7 +17269,7 @@
         </p:blipFill>
         <p:spPr>
           <a:xfrm>
-            <a:off x="8565643" y="6848361"/>
+            <a:off x="8839200" y="6972300"/>
             <a:ext cx="3200400" cy="3200400"/>
           </a:xfrm>
           <a:prstGeom prst="rect">

</xml_diff>